<commit_message>
Shorten the title, reduce the objectives and add the methodology to the first-stage report
Changes asked for by the supervisor after reviewing the first-stage report
and slides:

- Title is now "Label Noise in Just-In-Time Software Defect Prediction".
- The six objectives are reduced to three main objectives, which are
  stated before the research questions. Each research question names the
  objective it belongs to.
- The first-stage report has a new chapter, "Proposed Methodology",
  written as planned work without results. The closing chapter is
  shortened accordingly and the last paragraph of the abstract is removed.
- The second-stage report uses the same title and objectives and now
  refers to its own work as the second stage.
- Slides: new title, objectives before research questions, methodology
  slides in the first-stage deck, and no timeline slide in that deck.
</commit_message>
<xml_diff>
--- a/MTP 1/presentation/mtp1_presentation.pptx
+++ b/MTP 1/presentation/mtp1_presentation.pptx
@@ -20,9 +20,10 @@
     <p:sldId id="268" r:id="rId14"/>
     <p:sldId id="269" r:id="rId15"/>
     <p:sldId id="270" r:id="rId16"/>
+    <p:sldId id="271" r:id="rId17"/>
   </p:sldIdLst>
   <p:notesMasterIdLst>
-    <p:notesMasterId r:id="rId17"/>
+    <p:notesMasterId r:id="rId18"/>
   </p:notesMasterIdLst>
   <p:sldSz cx="9144000" cy="5143500"/>
   <p:notesSz cx="5143500" cy="9144000"/>
@@ -121,47 +122,44 @@
   <p:extLst>
     <p:ext uri="{521415D9-36F7-43E2-AB2F-B90AF26B5E84}">
       <p14:sectionLst xmlns:p14="http://schemas.microsoft.com/office/powerpoint/2010/main">
-        <p14:section name="Title" id="{f49ed903-f3ad-8d20-275d-75da344e1cde}">
+        <p14:section name="Title" id="{d8c265df-ef39-a75d-d7ea-94fd902cfc0b}">
           <p14:sldIdLst>
             <p14:sldId id="256"/>
             <p14:sldId id="257"/>
           </p14:sldIdLst>
         </p14:section>
-        <p14:section name="Overview and motivation" id="{d1bc3eeb-0769-a781-def0-1b345154e990}">
+        <p14:section name="Overview and motivation" id="{da6b8bb0-5592-aa9f-a237-55a2f2f592c4}">
           <p14:sldIdLst>
             <p14:sldId id="258"/>
             <p14:sldId id="259"/>
             <p14:sldId id="260"/>
           </p14:sldIdLst>
         </p14:section>
-        <p14:section name="Related works" id="{6a0a8f06-e86e-9084-64f7-10f09404bc57}">
+        <p14:section name="Related works" id="{0863df89-89ab-58a3-3f64-ea4d1c3649bb}">
           <p14:sldIdLst>
             <p14:sldId id="261"/>
             <p14:sldId id="262"/>
           </p14:sldIdLst>
         </p14:section>
-        <p14:section name="Research gaps and objectives" id="{cb8ef58d-218e-9700-b6fa-aedd665e9363}">
+        <p14:section name="Research gaps and objectives" id="{d2fdaea1-ed90-71fc-b258-cc20565911ba}">
           <p14:sldIdLst>
             <p14:sldId id="263"/>
             <p14:sldId id="264"/>
             <p14:sldId id="265"/>
           </p14:sldIdLst>
         </p14:section>
-        <p14:section name="Dataset and proposed work" id="{6b79c634-cb3f-44ec-f4d1-a972bce0e184}">
+        <p14:section name="Dataset and methodology" id="{69d20737-0485-ee73-3be8-5f64d985487e}">
           <p14:sldIdLst>
             <p14:sldId id="266"/>
             <p14:sldId id="267"/>
+            <p14:sldId id="268"/>
+            <p14:sldId id="269"/>
           </p14:sldIdLst>
         </p14:section>
-        <p14:section name="Timeline" id="{072c5fde-6189-bb32-d8d8-3b9a4f4bd318}">
+        <p14:section name="References" id="{2ea88134-1eac-4c90-f773-6c685bdd52ab}">
           <p14:sldIdLst>
-            <p14:sldId id="268"/>
-          </p14:sldIdLst>
-        </p14:section>
-        <p14:section name="References" id="{a2137906-b92e-d6be-1996-4d007376d30b}">
-          <p14:sldIdLst>
-            <p14:sldId id="269"/>
             <p14:sldId id="270"/>
+            <p14:sldId id="271"/>
           </p14:sldIdLst>
         </p14:section>
       </p14:sectionLst>
@@ -1138,6 +1136,94 @@
 </p:notes>
 </file>
 
+<file path=ppt/notesSlides/notesSlide16.xml><?xml version="1.0" encoding="utf-8"?>
+<p:notes xmlns:a="http://schemas.openxmlformats.org/drawingml/2006/main" xmlns:r="http://schemas.openxmlformats.org/officeDocument/2006/relationships" xmlns:p="http://schemas.openxmlformats.org/presentationml/2006/main">
+  <p:cSld>
+    <p:spTree>
+      <p:nvGrpSpPr>
+        <p:cNvPr id="1" name=""/>
+        <p:cNvGrpSpPr/>
+        <p:nvPr/>
+      </p:nvGrpSpPr>
+      <p:grpSpPr>
+        <a:xfrm>
+          <a:off x="0" y="0"/>
+          <a:ext cx="0" cy="0"/>
+          <a:chOff x="0" y="0"/>
+          <a:chExt cx="0" cy="0"/>
+        </a:xfrm>
+      </p:grpSpPr>
+      <p:sp>
+        <p:nvSpPr>
+          <p:cNvPr id="2" name="Slide Image Placeholder 1"/>
+          <p:cNvSpPr>
+            <a:spLocks noGrp="1" noRot="1" noChangeAspect="1"/>
+          </p:cNvSpPr>
+          <p:nvPr>
+            <p:ph type="sldImg"/>
+          </p:nvPr>
+        </p:nvSpPr>
+        <p:spPr/>
+      </p:sp>
+      <p:sp>
+        <p:nvSpPr>
+          <p:cNvPr id="3" name="Notes Placeholder 2"/>
+          <p:cNvSpPr>
+            <a:spLocks noGrp="1"/>
+          </p:cNvSpPr>
+          <p:nvPr>
+            <p:ph type="body" idx="1"/>
+          </p:nvPr>
+        </p:nvSpPr>
+        <p:spPr/>
+        <p:txBody>
+          <a:bodyPr/>
+          <a:lstStyle/>
+          <a:p>
+            <a:r>
+              <a:rPr lang="en-US" dirty="0"/>
+              <a:t/>
+            </a:r>
+            <a:endParaRPr lang="en-US" dirty="0"/>
+          </a:p>
+        </p:txBody>
+      </p:sp>
+      <p:sp>
+        <p:nvSpPr>
+          <p:cNvPr id="4" name="Slide Number Placeholder 3"/>
+          <p:cNvSpPr>
+            <a:spLocks noGrp="1"/>
+          </p:cNvSpPr>
+          <p:nvPr>
+            <p:ph type="sldNum" sz="quarter" idx="10"/>
+          </p:nvPr>
+        </p:nvSpPr>
+        <p:spPr/>
+        <p:txBody>
+          <a:bodyPr/>
+          <a:lstStyle/>
+          <a:p>
+            <a:fld id="{F7021451-1387-4CA6-816F-3879F97B5CBC}" type="slidenum">
+              <a:rPr lang="en-US"/>
+              <a:t>16</a:t>
+            </a:fld>
+            <a:endParaRPr lang="en-US"/>
+          </a:p>
+        </p:txBody>
+      </p:sp>
+    </p:spTree>
+    <p:extLst>
+      <p:ext uri="{BB962C8B-B14F-4D97-AF65-F5344CB8AC3E}">
+        <p14:creationId xmlns:p14="http://schemas.microsoft.com/office/powerpoint/2010/main" val="1024086991"/>
+      </p:ext>
+    </p:extLst>
+  </p:cSld>
+  <p:clrMapOvr>
+    <a:masterClrMapping/>
+  </p:clrMapOvr>
+</p:notes>
+</file>
+
 <file path=ppt/notesSlides/notesSlide2.xml><?xml version="1.0" encoding="utf-8"?>
 <p:notes xmlns:a="http://schemas.openxmlformats.org/drawingml/2006/main" xmlns:r="http://schemas.openxmlformats.org/officeDocument/2006/relationships" xmlns:p="http://schemas.openxmlformats.org/presentationml/2006/main">
   <p:cSld>
@@ -1899,8 +1985,8 @@
         </p:nvSpPr>
         <p:spPr>
           <a:xfrm>
-            <a:off x="274320" y="457200"/>
-            <a:ext cx="8595360" cy="1261872"/>
+            <a:off x="274320" y="566928"/>
+            <a:ext cx="8595360" cy="1005840"/>
           </a:xfrm>
           <a:prstGeom prst="rect">
             <a:avLst/>
@@ -1913,7 +1999,7 @@
           <a:lstStyle>
             <a:lvl1pPr algn="ctr" indent="0" marL="0">
               <a:buNone/>
-              <a:defRPr lang="en-US" sz="2400" dirty="0">
+              <a:defRPr lang="en-US" sz="2600" dirty="0">
                 <a:solidFill>
                   <a:schemeClr val="bg1"/>
                 </a:solidFill>
@@ -1924,7 +2010,7 @@
             <a:pPr algn="ctr" indent="0" marL="0">
               <a:buNone/>
             </a:pPr>
-            <a:endParaRPr lang="en-US" sz="2400" dirty="0"/>
+            <a:endParaRPr lang="en-US" sz="2600" dirty="0"/>
           </a:p>
         </p:txBody>
       </p:sp>
@@ -1958,7 +2044,7 @@
                   <a:schemeClr val="tx1"/>
                 </a:solidFill>
               </a:rPr>
-              <a:t>/ 15</a:t>
+              <a:t>/ 16</a:t>
             </a:r>
             <a:endParaRPr lang="en-US" sz="800" dirty="0"/>
           </a:p>
@@ -2162,7 +2248,7 @@
                   <a:schemeClr val="tx1"/>
                 </a:solidFill>
               </a:rPr>
-              <a:t>/ 15</a:t>
+              <a:t>/ 16</a:t>
             </a:r>
             <a:endParaRPr lang="en-US" sz="800" dirty="0"/>
           </a:p>
@@ -2327,7 +2413,7 @@
                   <a:schemeClr val="tx1"/>
                 </a:solidFill>
               </a:rPr>
-              <a:t>/ 15</a:t>
+              <a:t>/ 16</a:t>
             </a:r>
             <a:endParaRPr lang="en-US" sz="800" dirty="0"/>
           </a:p>
@@ -2736,12 +2822,12 @@
         </p:nvSpPr>
         <p:spPr>
           <a:xfrm>
-            <a:off x="146304" y="457200"/>
-            <a:ext cx="8851392" cy="1261872"/>
+            <a:off x="146304" y="566928"/>
+            <a:ext cx="8851392" cy="1005840"/>
           </a:xfrm>
           <a:prstGeom prst="roundRect">
             <a:avLst>
-              <a:gd name="adj" fmla="val 5072"/>
+              <a:gd name="adj" fmla="val 6364"/>
             </a:avLst>
           </a:prstGeom>
           <a:solidFill>
@@ -2772,8 +2858,8 @@
         </p:nvSpPr>
         <p:spPr>
           <a:xfrm>
-            <a:off x="274320" y="457200"/>
-            <a:ext cx="8595360" cy="1261872"/>
+            <a:off x="274320" y="566928"/>
+            <a:ext cx="8595360" cy="1005840"/>
           </a:xfrm>
           <a:prstGeom prst="rect">
             <a:avLst/>
@@ -2789,14 +2875,14 @@
               <a:buNone/>
             </a:pPr>
             <a:r>
-              <a:rPr lang="en-US" sz="2400" dirty="0">
+              <a:rPr lang="en-US" sz="2600" dirty="0">
                 <a:solidFill>
                   <a:schemeClr val="bg1"/>
                 </a:solidFill>
               </a:rPr>
-              <a:t>Quantifying SZZ-Induced Label Noise in Just-In-Time Software Defect Prediction under Verification-Latency-Aware Online Evaluation</a:t>
-            </a:r>
-            <a:endParaRPr lang="en-US" sz="2400" dirty="0"/>
+              <a:t>Label Noise in Just-In-Time Software Defect Prediction</a:t>
+            </a:r>
+            <a:endParaRPr lang="en-US" sz="2600" dirty="0"/>
           </a:p>
         </p:txBody>
       </p:sp>
@@ -3118,7 +3204,7 @@
                   <a:schemeClr val="bg1"/>
                 </a:solidFill>
               </a:rPr>
-              <a:t>Objectives</a:t>
+              <a:t>Research Questions</a:t>
             </a:r>
             <a:endParaRPr lang="en-US" sz="2400" dirty="0"/>
           </a:p>
@@ -3149,7 +3235,7 @@
           <a:p>
             <a:pPr marL="177800" indent="-177800">
               <a:spcAft>
-                <a:spcPts val="500"/>
+                <a:spcPts val="600"/>
               </a:spcAft>
               <a:buSzPct val="100000"/>
               <a:buChar char="•"/>
@@ -3160,7 +3246,7 @@
                   <a:schemeClr val="tx1"/>
                 </a:solidFill>
               </a:rPr>
-              <a:t>Objective 1: </a:t>
+              <a:t>RQ1: </a:t>
             </a:r>
             <a:r>
               <a:rPr lang="en-US" sz="1700" dirty="0">
@@ -3168,14 +3254,14 @@
                   <a:schemeClr val="tx1"/>
                 </a:solidFill>
               </a:rPr>
-              <a:t>Generate the labels of six SZZ variants for a dataset with independent reference labels, and characterise their false positive and false negative rates.</a:t>
+              <a:t>How much do the labels of SZZ variants disagree with one another and with independent reference labels, and what type of error does each variant make?</a:t>
             </a:r>
             <a:endParaRPr lang="en-US" sz="1700" dirty="0"/>
           </a:p>
           <a:p>
             <a:pPr marL="177800" indent="-177800">
               <a:spcAft>
-                <a:spcPts val="500"/>
+                <a:spcPts val="600"/>
               </a:spcAft>
               <a:buSzPct val="100000"/>
               <a:buChar char="•"/>
@@ -3186,7 +3272,7 @@
                   <a:schemeClr val="tx1"/>
                 </a:solidFill>
               </a:rPr>
-              <a:t>Objective 2: </a:t>
+              <a:t>RQ2: </a:t>
             </a:r>
             <a:r>
               <a:rPr lang="en-US" sz="1700" dirty="0">
@@ -3194,14 +3280,14 @@
                   <a:schemeClr val="tx1"/>
                 </a:solidFill>
               </a:rPr>
-              <a:t>Examine the agreement between the variants and identify the sources of their errors.</a:t>
+              <a:t>How does the choice of the label source affect the measured performance of JIT-SDP models under different evaluation settings?</a:t>
             </a:r>
             <a:endParaRPr lang="en-US" sz="1700" dirty="0"/>
           </a:p>
           <a:p>
             <a:pPr marL="177800" indent="-177800">
               <a:spcAft>
-                <a:spcPts val="500"/>
+                <a:spcPts val="600"/>
               </a:spcAft>
               <a:buSzPct val="100000"/>
               <a:buChar char="•"/>
@@ -3212,7 +3298,7 @@
                   <a:schemeClr val="tx1"/>
                 </a:solidFill>
               </a:rPr>
-              <a:t>Objective 3: </a:t>
+              <a:t>RQ3: </a:t>
             </a:r>
             <a:r>
               <a:rPr lang="en-US" sz="1700" dirty="0">
@@ -3220,14 +3306,14 @@
                   <a:schemeClr val="tx1"/>
                 </a:solidFill>
               </a:rPr>
-              <a:t>Measure how much the evaluation procedure changes the measured performance of JIT-SDP models.</a:t>
+              <a:t>Through which mechanism does label noise reduce the performance of an online learner, and which type of error is responsible?</a:t>
             </a:r>
             <a:endParaRPr lang="en-US" sz="1700" dirty="0"/>
           </a:p>
           <a:p>
             <a:pPr marL="177800" indent="-177800">
               <a:spcAft>
-                <a:spcPts val="500"/>
+                <a:spcPts val="600"/>
               </a:spcAft>
               <a:buSzPct val="100000"/>
               <a:buChar char="•"/>
@@ -3238,7 +3324,7 @@
                   <a:schemeClr val="tx1"/>
                 </a:solidFill>
               </a:rPr>
-              <a:t>Objective 4: </a:t>
+              <a:t>RQ4: </a:t>
             </a:r>
             <a:r>
               <a:rPr lang="en-US" sz="1700" dirty="0">
@@ -3246,59 +3332,7 @@
                   <a:schemeClr val="tx1"/>
                 </a:solidFill>
               </a:rPr>
-              <a:t>Measure the loss caused by SZZ labels for an online learner under verification latency.</a:t>
-            </a:r>
-            <a:endParaRPr lang="en-US" sz="1700" dirty="0"/>
-          </a:p>
-          <a:p>
-            <a:pPr marL="177800" indent="-177800">
-              <a:spcAft>
-                <a:spcPts val="500"/>
-              </a:spcAft>
-              <a:buSzPct val="100000"/>
-              <a:buChar char="•"/>
-            </a:pPr>
-            <a:r>
-              <a:rPr lang="en-US" sz="1700" b="1" dirty="0">
-                <a:solidFill>
-                  <a:schemeClr val="tx1"/>
-                </a:solidFill>
-              </a:rPr>
-              <a:t>Objective 5: </a:t>
-            </a:r>
-            <a:r>
-              <a:rPr lang="en-US" sz="1700" dirty="0">
-                <a:solidFill>
-                  <a:schemeClr val="tx1"/>
-                </a:solidFill>
-              </a:rPr>
-              <a:t>Identify the type of labelling error responsible for the loss and its mechanism.</a:t>
-            </a:r>
-            <a:endParaRPr lang="en-US" sz="1700" dirty="0"/>
-          </a:p>
-          <a:p>
-            <a:pPr marL="177800" indent="-177800">
-              <a:spcAft>
-                <a:spcPts val="500"/>
-              </a:spcAft>
-              <a:buSzPct val="100000"/>
-              <a:buChar char="•"/>
-            </a:pPr>
-            <a:r>
-              <a:rPr lang="en-US" sz="1700" b="1" dirty="0">
-                <a:solidFill>
-                  <a:schemeClr val="tx1"/>
-                </a:solidFill>
-              </a:rPr>
-              <a:t>Objective 6: </a:t>
-            </a:r>
-            <a:r>
-              <a:rPr lang="en-US" sz="1700" dirty="0">
-                <a:solidFill>
-                  <a:schemeClr val="tx1"/>
-                </a:solidFill>
-              </a:rPr>
-              <a:t>Design and evaluate a noise-aware online learner.</a:t>
+              <a:t>Can an online learner be made less sensitive to SZZ label noise without access to clean labels?</a:t>
             </a:r>
             <a:endParaRPr lang="en-US" sz="1700" dirty="0"/>
           </a:p>
@@ -3712,7 +3746,7 @@
                   <a:schemeClr val="bg1"/>
                 </a:solidFill>
               </a:rPr>
-              <a:t>Proposed Work</a:t>
+              <a:t>Proposed Methodology</a:t>
             </a:r>
             <a:endParaRPr lang="en-US" sz="2400" dirty="0"/>
           </a:p>
@@ -3888,7 +3922,7 @@
                   <a:schemeClr val="bg1"/>
                 </a:solidFill>
               </a:rPr>
-              <a:t>Timeline</a:t>
+              <a:t>Proposed Methodology</a:t>
             </a:r>
             <a:endParaRPr lang="en-US" sz="2400" dirty="0"/>
           </a:p>
@@ -3896,467 +3930,16 @@
       </p:sp>
       <p:sp>
         <p:nvSpPr>
-          <p:cNvPr id="3" name="Timeline arrow"/>
+          <p:cNvPr id="3" name="Text 1"/>
           <p:cNvSpPr/>
-          <p:nvPr/>
+          <p:nvPr>
+            <p:ph idx="102" type="body" hasCustomPrompt="1"/>
+          </p:nvPr>
         </p:nvSpPr>
         <p:spPr>
           <a:xfrm>
-            <a:off x="457200" y="2395728"/>
-            <a:ext cx="8229600" cy="310896"/>
-          </a:xfrm>
-          <a:prstGeom prst="rightArrow">
-            <a:avLst/>
-          </a:prstGeom>
-          <a:solidFill>
-            <a:schemeClr val="bg1"/>
-          </a:solidFill>
-          <a:ln w="12700">
-            <a:solidFill>
-              <a:schemeClr val="tx1"/>
-            </a:solidFill>
-            <a:prstDash val="solid"/>
-          </a:ln>
-        </p:spPr>
-      </p:sp>
-      <p:sp>
-        <p:nvSpPr>
-          <p:cNvPr id="4" name="Connector 1"/>
-          <p:cNvSpPr/>
-          <p:nvPr/>
-        </p:nvSpPr>
-        <p:spPr>
-          <a:xfrm>
-            <a:off x="1463040" y="1874520"/>
-            <a:ext cx="0" cy="576072"/>
-          </a:xfrm>
-          <a:prstGeom prst="line">
-            <a:avLst/>
-          </a:prstGeom>
-          <a:noFill/>
-          <a:ln w="12700">
-            <a:solidFill>
-              <a:schemeClr val="tx1"/>
-            </a:solidFill>
-            <a:prstDash val="dash"/>
-          </a:ln>
-        </p:spPr>
-      </p:sp>
-      <p:sp>
-        <p:nvSpPr>
-          <p:cNvPr id="5" name="Stage 1"/>
-          <p:cNvSpPr txBox="1"/>
-          <p:nvPr/>
-        </p:nvSpPr>
-        <p:spPr>
-          <a:xfrm>
-            <a:off x="548640" y="960120"/>
-            <a:ext cx="1828800" cy="914400"/>
-          </a:xfrm>
-          <a:prstGeom prst="rect">
-            <a:avLst/>
-          </a:prstGeom>
-          <a:solidFill>
-            <a:schemeClr val="bg1"/>
-          </a:solidFill>
-          <a:ln w="12700">
-            <a:solidFill>
-              <a:schemeClr val="tx1"/>
-            </a:solidFill>
-          </a:ln>
-        </p:spPr>
-        <p:txBody>
-          <a:bodyPr wrap="square" lIns="38100" tIns="38100" rIns="38100" bIns="38100" rtlCol="0" anchor="ctr"/>
-          <a:lstStyle/>
-          <a:p>
-            <a:pPr algn="ctr" indent="0" marL="0">
-              <a:buNone/>
-            </a:pPr>
-            <a:r>
-              <a:rPr lang="en-US" sz="1150" b="1" dirty="0">
-                <a:solidFill>
-                  <a:schemeClr val="tx1"/>
-                </a:solidFill>
-              </a:rPr>
-              <a:t>MTP I</a:t>
-            </a:r>
-            <a:endParaRPr lang="en-US" sz="1150" dirty="0"/>
-          </a:p>
-          <a:p>
-            <a:pPr algn="ctr" indent="0" marL="0">
-              <a:buNone/>
-            </a:pPr>
-            <a:r>
-              <a:rPr lang="en-US" sz="1150" dirty="0">
-                <a:solidFill>
-                  <a:schemeClr val="tx1"/>
-                </a:solidFill>
-              </a:rPr>
-              <a:t>Literature Survey</a:t>
-            </a:r>
-            <a:endParaRPr lang="en-US" sz="1150" dirty="0"/>
-          </a:p>
-          <a:p>
-            <a:pPr algn="ctr" indent="0" marL="0">
-              <a:buNone/>
-            </a:pPr>
-            <a:r>
-              <a:rPr lang="en-US" sz="1150" dirty="0">
-                <a:solidFill>
-                  <a:schemeClr val="tx1"/>
-                </a:solidFill>
-              </a:rPr>
-              <a:t>(Research Gaps,</a:t>
-            </a:r>
-            <a:endParaRPr lang="en-US" sz="1150" dirty="0"/>
-          </a:p>
-          <a:p>
-            <a:pPr algn="ctr" indent="0" marL="0">
-              <a:buNone/>
-            </a:pPr>
-            <a:r>
-              <a:rPr lang="en-US" sz="1150" dirty="0">
-                <a:solidFill>
-                  <a:schemeClr val="tx1"/>
-                </a:solidFill>
-              </a:rPr>
-              <a:t>Dataset)</a:t>
-            </a:r>
-            <a:endParaRPr lang="en-US" sz="1150" dirty="0"/>
-          </a:p>
-        </p:txBody>
-      </p:sp>
-      <p:sp>
-        <p:nvSpPr>
-          <p:cNvPr id="6" name="Connector 2"/>
-          <p:cNvSpPr/>
-          <p:nvPr/>
-        </p:nvSpPr>
-        <p:spPr>
-          <a:xfrm>
-            <a:off x="3538728" y="2651760"/>
-            <a:ext cx="0" cy="594360"/>
-          </a:xfrm>
-          <a:prstGeom prst="line">
-            <a:avLst/>
-          </a:prstGeom>
-          <a:noFill/>
-          <a:ln w="12700">
-            <a:solidFill>
-              <a:schemeClr val="tx1"/>
-            </a:solidFill>
-            <a:prstDash val="dash"/>
-          </a:ln>
-        </p:spPr>
-      </p:sp>
-      <p:sp>
-        <p:nvSpPr>
-          <p:cNvPr id="7" name="Stage 2"/>
-          <p:cNvSpPr txBox="1"/>
-          <p:nvPr/>
-        </p:nvSpPr>
-        <p:spPr>
-          <a:xfrm>
-            <a:off x="2624328" y="3246120"/>
-            <a:ext cx="1828800" cy="914400"/>
-          </a:xfrm>
-          <a:prstGeom prst="rect">
-            <a:avLst/>
-          </a:prstGeom>
-          <a:solidFill>
-            <a:schemeClr val="bg1"/>
-          </a:solidFill>
-          <a:ln w="12700">
-            <a:solidFill>
-              <a:schemeClr val="tx1"/>
-            </a:solidFill>
-          </a:ln>
-        </p:spPr>
-        <p:txBody>
-          <a:bodyPr wrap="square" lIns="38100" tIns="38100" rIns="38100" bIns="38100" rtlCol="0" anchor="ctr"/>
-          <a:lstStyle/>
-          <a:p>
-            <a:pPr algn="ctr" indent="0" marL="0">
-              <a:buNone/>
-            </a:pPr>
-            <a:r>
-              <a:rPr lang="en-US" sz="1150" b="1" dirty="0">
-                <a:solidFill>
-                  <a:schemeClr val="tx1"/>
-                </a:solidFill>
-              </a:rPr>
-              <a:t>MTP II</a:t>
-            </a:r>
-            <a:endParaRPr lang="en-US" sz="1150" dirty="0"/>
-          </a:p>
-          <a:p>
-            <a:pPr algn="ctr" indent="0" marL="0">
-              <a:buNone/>
-            </a:pPr>
-            <a:r>
-              <a:rPr lang="en-US" sz="1150" dirty="0">
-                <a:solidFill>
-                  <a:schemeClr val="tx1"/>
-                </a:solidFill>
-              </a:rPr>
-              <a:t>Label Quality and</a:t>
-            </a:r>
-            <a:endParaRPr lang="en-US" sz="1150" dirty="0"/>
-          </a:p>
-          <a:p>
-            <a:pPr algn="ctr" indent="0" marL="0">
-              <a:buNone/>
-            </a:pPr>
-            <a:r>
-              <a:rPr lang="en-US" sz="1150" dirty="0">
-                <a:solidFill>
-                  <a:schemeClr val="tx1"/>
-                </a:solidFill>
-              </a:rPr>
-              <a:t>Impact Analysis</a:t>
-            </a:r>
-            <a:endParaRPr lang="en-US" sz="1150" dirty="0"/>
-          </a:p>
-          <a:p>
-            <a:pPr algn="ctr" indent="0" marL="0">
-              <a:buNone/>
-            </a:pPr>
-            <a:r>
-              <a:rPr lang="en-US" sz="1150" dirty="0">
-                <a:solidFill>
-                  <a:schemeClr val="tx1"/>
-                </a:solidFill>
-              </a:rPr>
-              <a:t>(RQ1, RQ2)</a:t>
-            </a:r>
-            <a:endParaRPr lang="en-US" sz="1150" dirty="0"/>
-          </a:p>
-        </p:txBody>
-      </p:sp>
-      <p:sp>
-        <p:nvSpPr>
-          <p:cNvPr id="8" name="Connector 3"/>
-          <p:cNvSpPr/>
-          <p:nvPr/>
-        </p:nvSpPr>
-        <p:spPr>
-          <a:xfrm>
-            <a:off x="5605272" y="1874520"/>
-            <a:ext cx="0" cy="576072"/>
-          </a:xfrm>
-          <a:prstGeom prst="line">
-            <a:avLst/>
-          </a:prstGeom>
-          <a:noFill/>
-          <a:ln w="12700">
-            <a:solidFill>
-              <a:schemeClr val="tx1"/>
-            </a:solidFill>
-            <a:prstDash val="dash"/>
-          </a:ln>
-        </p:spPr>
-      </p:sp>
-      <p:sp>
-        <p:nvSpPr>
-          <p:cNvPr id="9" name="Stage 3"/>
-          <p:cNvSpPr txBox="1"/>
-          <p:nvPr/>
-        </p:nvSpPr>
-        <p:spPr>
-          <a:xfrm>
-            <a:off x="4690872" y="960120"/>
-            <a:ext cx="1828800" cy="914400"/>
-          </a:xfrm>
-          <a:prstGeom prst="rect">
-            <a:avLst/>
-          </a:prstGeom>
-          <a:solidFill>
-            <a:schemeClr val="bg1"/>
-          </a:solidFill>
-          <a:ln w="12700">
-            <a:solidFill>
-              <a:schemeClr val="tx1"/>
-            </a:solidFill>
-          </a:ln>
-        </p:spPr>
-        <p:txBody>
-          <a:bodyPr wrap="square" lIns="38100" tIns="38100" rIns="38100" bIns="38100" rtlCol="0" anchor="ctr"/>
-          <a:lstStyle/>
-          <a:p>
-            <a:pPr algn="ctr" indent="0" marL="0">
-              <a:buNone/>
-            </a:pPr>
-            <a:r>
-              <a:rPr lang="en-US" sz="1150" b="1" dirty="0">
-                <a:solidFill>
-                  <a:schemeClr val="tx1"/>
-                </a:solidFill>
-              </a:rPr>
-              <a:t>MTP III</a:t>
-            </a:r>
-            <a:endParaRPr lang="en-US" sz="1150" dirty="0"/>
-          </a:p>
-          <a:p>
-            <a:pPr algn="ctr" indent="0" marL="0">
-              <a:buNone/>
-            </a:pPr>
-            <a:r>
-              <a:rPr lang="en-US" sz="1150" dirty="0">
-                <a:solidFill>
-                  <a:schemeClr val="tx1"/>
-                </a:solidFill>
-              </a:rPr>
-              <a:t>Mechanism of the</a:t>
-            </a:r>
-            <a:endParaRPr lang="en-US" sz="1150" dirty="0"/>
-          </a:p>
-          <a:p>
-            <a:pPr algn="ctr" indent="0" marL="0">
-              <a:buNone/>
-            </a:pPr>
-            <a:r>
-              <a:rPr lang="en-US" sz="1150" dirty="0">
-                <a:solidFill>
-                  <a:schemeClr val="tx1"/>
-                </a:solidFill>
-              </a:rPr>
-              <a:t>Noise Effect</a:t>
-            </a:r>
-            <a:endParaRPr lang="en-US" sz="1150" dirty="0"/>
-          </a:p>
-          <a:p>
-            <a:pPr algn="ctr" indent="0" marL="0">
-              <a:buNone/>
-            </a:pPr>
-            <a:r>
-              <a:rPr lang="en-US" sz="1150" dirty="0">
-                <a:solidFill>
-                  <a:schemeClr val="tx1"/>
-                </a:solidFill>
-              </a:rPr>
-              <a:t>(RQ3)</a:t>
-            </a:r>
-            <a:endParaRPr lang="en-US" sz="1150" dirty="0"/>
-          </a:p>
-        </p:txBody>
-      </p:sp>
-      <p:sp>
-        <p:nvSpPr>
-          <p:cNvPr id="10" name="Connector 4"/>
-          <p:cNvSpPr/>
-          <p:nvPr/>
-        </p:nvSpPr>
-        <p:spPr>
-          <a:xfrm>
-            <a:off x="7680960" y="2651760"/>
-            <a:ext cx="0" cy="594360"/>
-          </a:xfrm>
-          <a:prstGeom prst="line">
-            <a:avLst/>
-          </a:prstGeom>
-          <a:noFill/>
-          <a:ln w="12700">
-            <a:solidFill>
-              <a:schemeClr val="tx1"/>
-            </a:solidFill>
-            <a:prstDash val="dash"/>
-          </a:ln>
-        </p:spPr>
-      </p:sp>
-      <p:sp>
-        <p:nvSpPr>
-          <p:cNvPr id="11" name="Stage 4"/>
-          <p:cNvSpPr txBox="1"/>
-          <p:nvPr/>
-        </p:nvSpPr>
-        <p:spPr>
-          <a:xfrm>
-            <a:off x="6766560" y="3246120"/>
-            <a:ext cx="1828800" cy="914400"/>
-          </a:xfrm>
-          <a:prstGeom prst="rect">
-            <a:avLst/>
-          </a:prstGeom>
-          <a:solidFill>
-            <a:schemeClr val="bg1"/>
-          </a:solidFill>
-          <a:ln w="12700">
-            <a:solidFill>
-              <a:schemeClr val="tx1"/>
-            </a:solidFill>
-          </a:ln>
-        </p:spPr>
-        <p:txBody>
-          <a:bodyPr wrap="square" lIns="38100" tIns="38100" rIns="38100" bIns="38100" rtlCol="0" anchor="ctr"/>
-          <a:lstStyle/>
-          <a:p>
-            <a:pPr algn="ctr" indent="0" marL="0">
-              <a:buNone/>
-            </a:pPr>
-            <a:r>
-              <a:rPr lang="en-US" sz="1150" b="1" dirty="0">
-                <a:solidFill>
-                  <a:schemeClr val="tx1"/>
-                </a:solidFill>
-              </a:rPr>
-              <a:t>MTP IV</a:t>
-            </a:r>
-            <a:endParaRPr lang="en-US" sz="1150" dirty="0"/>
-          </a:p>
-          <a:p>
-            <a:pPr algn="ctr" indent="0" marL="0">
-              <a:buNone/>
-            </a:pPr>
-            <a:r>
-              <a:rPr lang="en-US" sz="1150" dirty="0">
-                <a:solidFill>
-                  <a:schemeClr val="tx1"/>
-                </a:solidFill>
-              </a:rPr>
-              <a:t>Noise-Aware</a:t>
-            </a:r>
-            <a:endParaRPr lang="en-US" sz="1150" dirty="0"/>
-          </a:p>
-          <a:p>
-            <a:pPr algn="ctr" indent="0" marL="0">
-              <a:buNone/>
-            </a:pPr>
-            <a:r>
-              <a:rPr lang="en-US" sz="1150" dirty="0">
-                <a:solidFill>
-                  <a:schemeClr val="tx1"/>
-                </a:solidFill>
-              </a:rPr>
-              <a:t>Online Learner</a:t>
-            </a:r>
-            <a:endParaRPr lang="en-US" sz="1150" dirty="0"/>
-          </a:p>
-          <a:p>
-            <a:pPr algn="ctr" indent="0" marL="0">
-              <a:buNone/>
-            </a:pPr>
-            <a:r>
-              <a:rPr lang="en-US" sz="1150" dirty="0">
-                <a:solidFill>
-                  <a:schemeClr val="tx1"/>
-                </a:solidFill>
-              </a:rPr>
-              <a:t>(RQ4)</a:t>
-            </a:r>
-            <a:endParaRPr lang="en-US" sz="1150" dirty="0"/>
-          </a:p>
-        </p:txBody>
-      </p:sp>
-      <p:sp>
-        <p:nvSpPr>
-          <p:cNvPr id="12" name="Caption 5"/>
-          <p:cNvSpPr txBox="1"/>
-          <p:nvPr/>
-        </p:nvSpPr>
-        <p:spPr>
-          <a:xfrm>
-            <a:off x="2743200" y="4343400"/>
-            <a:ext cx="3657600" cy="384048"/>
+            <a:off x="411480" y="777240"/>
+            <a:ext cx="8321040" cy="3931920"/>
           </a:xfrm>
           <a:prstGeom prst="rect">
             <a:avLst/>
@@ -4365,29 +3948,163 @@
           <a:ln/>
         </p:spPr>
         <p:txBody>
-          <a:bodyPr wrap="square" lIns="0" tIns="0" rIns="0" bIns="0" rtlCol="0" anchor="t"/>
+          <a:bodyPr wrap="square" rtlCol="0" anchor="ctr"/>
           <a:lstStyle/>
           <a:p>
-            <a:pPr algn="ctr" indent="0" marL="0">
-              <a:buNone/>
+            <a:pPr marL="177800" indent="-177800">
+              <a:spcAft>
+                <a:spcPts val="500"/>
+              </a:spcAft>
+              <a:buSzPct val="100000"/>
+              <a:buChar char="•"/>
             </a:pPr>
             <a:r>
-              <a:rPr lang="en-US" sz="1150" dirty="0">
-                <a:solidFill>
-                  <a:schemeClr val="tx2"/>
+              <a:rPr lang="en-US" sz="1700" b="1" dirty="0">
+                <a:solidFill>
+                  <a:schemeClr val="tx1"/>
                 </a:solidFill>
               </a:rPr>
-              <a:t>Figure 5: </a:t>
-            </a:r>
-            <a:r>
-              <a:rPr lang="en-US" sz="1150" dirty="0">
+              <a:t>SZZ labels: </a:t>
+            </a:r>
+            <a:r>
+              <a:rPr lang="en-US" sz="1700" dirty="0">
                 <a:solidFill>
                   <a:schemeClr val="tx1"/>
                 </a:solidFill>
               </a:rPr>
-              <a:t>Timeline</a:t>
-            </a:r>
-            <a:endParaRPr lang="en-US" sz="1150" dirty="0"/>
+              <a:t>six variants (B-, AG-, MA-, L-, R- and RA-SZZ) will be run with PySZZ on the same 5,453 bug-fixing commits</a:t>
+            </a:r>
+            <a:endParaRPr lang="en-US" sz="1700" dirty="0"/>
+          </a:p>
+          <a:p>
+            <a:pPr marL="177800" indent="-177800">
+              <a:spcAft>
+                <a:spcPts val="500"/>
+              </a:spcAft>
+              <a:buSzPct val="100000"/>
+              <a:buChar char="•"/>
+            </a:pPr>
+            <a:r>
+              <a:rPr lang="en-US" sz="1700" b="1" dirty="0">
+                <a:solidFill>
+                  <a:schemeClr val="tx1"/>
+                </a:solidFill>
+              </a:rPr>
+              <a:t>Label quality: </a:t>
+            </a:r>
+            <a:r>
+              <a:rPr lang="en-US" sz="1700" dirty="0">
+                <a:solidFill>
+                  <a:schemeClr val="tx1"/>
+                </a:solidFill>
+              </a:rPr>
+              <a:t>precision, recall, false-alarm rate ρ₀, miss rate ρ₁ and Cohen's κ against the reference labels</a:t>
+            </a:r>
+            <a:endParaRPr lang="en-US" sz="1700" dirty="0"/>
+          </a:p>
+          <a:p>
+            <a:pPr marL="177800" indent="-177800">
+              <a:spcAft>
+                <a:spcPts val="500"/>
+              </a:spcAft>
+              <a:buSzPct val="100000"/>
+              <a:buChar char="•"/>
+            </a:pPr>
+            <a:r>
+              <a:rPr lang="en-US" sz="1700" b="1" dirty="0">
+                <a:solidFill>
+                  <a:schemeClr val="tx1"/>
+                </a:solidFill>
+              </a:rPr>
+              <a:t>Models: </a:t>
+            </a:r>
+            <a:r>
+              <a:rPr lang="en-US" sz="1700" dirty="0">
+                <a:solidFill>
+                  <a:schemeClr val="tx1"/>
+                </a:solidFill>
+              </a:rPr>
+              <a:t>LApredict (logistic regression on lines added) [12], a JITLine-based random forest with SMOTE [9], and ORB (online ensemble) [1]</a:t>
+            </a:r>
+            <a:endParaRPr lang="en-US" sz="1700" dirty="0"/>
+          </a:p>
+          <a:p>
+            <a:pPr marL="177800" indent="-177800">
+              <a:spcAft>
+                <a:spcPts val="500"/>
+              </a:spcAft>
+              <a:buSzPct val="100000"/>
+              <a:buChar char="•"/>
+            </a:pPr>
+            <a:r>
+              <a:rPr lang="en-US" sz="1700" b="1" dirty="0">
+                <a:solidFill>
+                  <a:schemeClr val="tx1"/>
+                </a:solidFill>
+              </a:rPr>
+              <a:t>Scoring: </a:t>
+            </a:r>
+            <a:r>
+              <a:rPr lang="en-US" sz="1700" dirty="0">
+                <a:solidFill>
+                  <a:schemeClr val="tx1"/>
+                </a:solidFill>
+              </a:rPr>
+              <a:t>against the reference labels, and against the training labels (self-scoring) for comparison</a:t>
+            </a:r>
+            <a:endParaRPr lang="en-US" sz="1700" dirty="0"/>
+          </a:p>
+          <a:p>
+            <a:pPr marL="177800" indent="-177800">
+              <a:spcAft>
+                <a:spcPts val="500"/>
+              </a:spcAft>
+              <a:buSzPct val="100000"/>
+              <a:buChar char="•"/>
+            </a:pPr>
+            <a:r>
+              <a:rPr lang="en-US" sz="1700" b="1" dirty="0">
+                <a:solidFill>
+                  <a:schemeClr val="tx1"/>
+                </a:solidFill>
+              </a:rPr>
+              <a:t>Statistics: </a:t>
+            </a:r>
+            <a:r>
+              <a:rPr lang="en-US" sz="1700" dirty="0">
+                <a:solidFill>
+                  <a:schemeClr val="tx1"/>
+                </a:solidFill>
+              </a:rPr>
+              <a:t>paired by project (n = 21), Wilcoxon signed-rank test, Hodges-Lehmann estimate with bootstrap confidence interval, Holm correction for multiple comparisons</a:t>
+            </a:r>
+            <a:endParaRPr lang="en-US" sz="1700" dirty="0"/>
+          </a:p>
+          <a:p>
+            <a:pPr marL="177800" indent="-177800">
+              <a:spcAft>
+                <a:spcPts val="500"/>
+              </a:spcAft>
+              <a:buSzPct val="100000"/>
+              <a:buChar char="•"/>
+            </a:pPr>
+            <a:r>
+              <a:rPr lang="en-US" sz="1700" b="1" dirty="0">
+                <a:solidFill>
+                  <a:schemeClr val="tx1"/>
+                </a:solidFill>
+              </a:rPr>
+              <a:t>Planned scale: </a:t>
+            </a:r>
+            <a:r>
+              <a:rPr lang="en-US" sz="1700" dirty="0">
+                <a:solidFill>
+                  <a:schemeClr val="tx1"/>
+                </a:solidFill>
+              </a:rPr>
+              <a:t>3 models, 7 label sources, 4 evaluation settings, 10 seeds</a:t>
+            </a:r>
+            <a:endParaRPr lang="en-US" sz="1700" dirty="0"/>
           </a:p>
         </p:txBody>
       </p:sp>
@@ -4493,6 +4210,182 @@
                   <a:schemeClr val="bg1"/>
                 </a:solidFill>
               </a:rPr>
+              <a:t>Proposed Methodology: Evaluation Settings</a:t>
+            </a:r>
+            <a:endParaRPr lang="en-US" sz="2400" dirty="0"/>
+          </a:p>
+        </p:txBody>
+      </p:sp>
+      <p:pic>
+        <p:nvPicPr>
+          <p:cNvPr id="3" name="Figure 5" descr="/home/afler/Documents/thesis-later/scripts/presentation/images/settings.png">    </p:cNvPr>
+          <p:cNvPicPr>
+            <a:picLocks noChangeAspect="1"/>
+          </p:cNvPicPr>
+          <p:nvPr/>
+        </p:nvPicPr>
+        <p:blipFill>
+          <a:blip r:embed="rId1"/>
+          <a:stretch>
+            <a:fillRect/>
+          </a:stretch>
+        </p:blipFill>
+        <p:spPr>
+          <a:xfrm>
+            <a:off x="1234440" y="804672"/>
+            <a:ext cx="6675120" cy="3359396"/>
+          </a:xfrm>
+          <a:prstGeom prst="rect">
+            <a:avLst/>
+          </a:prstGeom>
+        </p:spPr>
+      </p:pic>
+      <p:sp>
+        <p:nvSpPr>
+          <p:cNvPr id="4" name="Caption 5"/>
+          <p:cNvSpPr txBox="1"/>
+          <p:nvPr/>
+        </p:nvSpPr>
+        <p:spPr>
+          <a:xfrm>
+            <a:off x="640080" y="4209788"/>
+            <a:ext cx="7863840" cy="384048"/>
+          </a:xfrm>
+          <a:prstGeom prst="rect">
+            <a:avLst/>
+          </a:prstGeom>
+          <a:noFill/>
+          <a:ln/>
+        </p:spPr>
+        <p:txBody>
+          <a:bodyPr wrap="square" lIns="0" tIns="0" rIns="0" bIns="0" rtlCol="0" anchor="t"/>
+          <a:lstStyle/>
+          <a:p>
+            <a:pPr algn="ctr" indent="0" marL="0">
+              <a:buNone/>
+            </a:pPr>
+            <a:r>
+              <a:rPr lang="en-US" sz="1150" dirty="0">
+                <a:solidFill>
+                  <a:schemeClr val="tx2"/>
+                </a:solidFill>
+              </a:rPr>
+              <a:t>Figure 5: </a:t>
+            </a:r>
+            <a:r>
+              <a:rPr lang="en-US" sz="1150" dirty="0">
+                <a:solidFill>
+                  <a:schemeClr val="tx1"/>
+                </a:solidFill>
+              </a:rPr>
+              <a:t>Evaluation settings. Commits of a project are ordered by time from left to right</a:t>
+            </a:r>
+            <a:endParaRPr lang="en-US" sz="1150" dirty="0"/>
+          </a:p>
+        </p:txBody>
+      </p:sp>
+      <p:sp>
+        <p:nvSpPr>
+          <p:cNvPr id="25" name="Slide Number Placeholder 0"/>
+          <p:cNvSpPr>
+            <a:spLocks noGrp="1"/>
+          </p:cNvSpPr>
+          <p:nvPr>
+            <p:ph type="sldNum" sz="quarter" idx="4294967295"/>
+          </p:nvPr>
+        </p:nvSpPr>
+        <p:spPr>
+          <a:xfrm>
+            <a:off x="8001000" y="4846320"/>
+            <a:ext cx="566928" cy="201168"/>
+          </a:xfrm>
+          <a:prstGeom prst="rect">
+            <a:avLst/>
+          </a:prstGeom>
+          <a:extLst>
+            <a:ext uri="{C572A759-6A51-4108-AA02-DFA0A04FC94B}">
+              <ma14:wrappingTextBoxFlag xmlns:ma14="http://schemas.microsoft.com/office/mac/drawingml/2011/main" val="0"/>
+            </a:ext>
+          </a:extLst>
+        </p:spPr>
+        <p:txBody>
+          <a:bodyPr lIns="0" tIns="0" rIns="0" bIns="0"/>
+          <a:lstStyle>
+            <a:lvl1pPr>
+              <a:defRPr sz="800">
+                <a:solidFill>
+                  <a:schemeClr val="tx1"/>
+                </a:solidFill>
+              </a:defRPr>
+            </a:lvl1pPr>
+          </a:lstStyle>
+          <a:p>
+            <a:pPr algn="r"/>
+            <a:fld id="{F7021451-1387-4CA6-816F-3879F97B5CBC}" type="slidenum">
+              <a:rPr b="0" lang="en-US"/>
+              <a:t>14</a:t>
+            </a:fld>
+            <a:endParaRPr lang="en-US"/>
+          </a:p>
+        </p:txBody>
+      </p:sp>
+    </p:spTree>
+  </p:cSld>
+  <p:clrMapOvr>
+    <a:masterClrMapping/>
+  </p:clrMapOvr>
+</p:sld>
+</file>
+
+<file path=ppt/slides/slide15.xml><?xml version="1.0" encoding="utf-8"?>
+<p:sld xmlns:a="http://schemas.openxmlformats.org/drawingml/2006/main" xmlns:r="http://schemas.openxmlformats.org/officeDocument/2006/relationships" xmlns:p="http://schemas.openxmlformats.org/presentationml/2006/main">
+  <p:cSld name="Slide 15">
+    <p:spTree>
+      <p:nvGrpSpPr>
+        <p:cNvPr id="1" name=""/>
+        <p:cNvGrpSpPr/>
+        <p:nvPr/>
+      </p:nvGrpSpPr>
+      <p:grpSpPr>
+        <a:xfrm>
+          <a:off x="0" y="0"/>
+          <a:ext cx="0" cy="0"/>
+          <a:chOff x="0" y="0"/>
+          <a:chExt cx="0" cy="0"/>
+        </a:xfrm>
+      </p:grpSpPr>
+      <p:sp>
+        <p:nvSpPr>
+          <p:cNvPr id="2" name="Text 1"/>
+          <p:cNvSpPr/>
+          <p:nvPr>
+            <p:ph idx="101" type="title" hasCustomPrompt="1"/>
+          </p:nvPr>
+        </p:nvSpPr>
+        <p:spPr>
+          <a:xfrm>
+            <a:off x="182880" y="0"/>
+            <a:ext cx="8778240" cy="621792"/>
+          </a:xfrm>
+          <a:prstGeom prst="rect">
+            <a:avLst/>
+          </a:prstGeom>
+          <a:noFill/>
+          <a:ln/>
+        </p:spPr>
+        <p:txBody>
+          <a:bodyPr wrap="square" lIns="0" tIns="0" rIns="0" bIns="0" rtlCol="0" anchor="ctr"/>
+          <a:lstStyle/>
+          <a:p>
+            <a:pPr algn="l" indent="0" marL="0">
+              <a:buNone/>
+            </a:pPr>
+            <a:r>
+              <a:rPr lang="en-US" sz="2400" dirty="0">
+                <a:solidFill>
+                  <a:schemeClr val="bg1"/>
+                </a:solidFill>
+              </a:rPr>
               <a:t>References I</a:t>
             </a:r>
             <a:endParaRPr lang="en-US" sz="2400" dirty="0"/>
@@ -4501,7 +4394,7 @@
       </p:sp>
       <p:graphicFrame>
         <p:nvGraphicFramePr>
-          <p:cNvPr id="15" name="Reference list"/>
+          <p:cNvPr id="16" name="Reference list"/>
           <p:cNvGraphicFramePr>
             <a:graphicFrameLocks noGrp="1"/>
           </p:cNvGraphicFramePr>
@@ -5256,7 +5149,7 @@
             <a:pPr algn="r"/>
             <a:fld id="{F7021451-1387-4CA6-816F-3879F97B5CBC}" type="slidenum">
               <a:rPr b="0" lang="en-US"/>
-              <a:t>14</a:t>
+              <a:t>15</a:t>
             </a:fld>
             <a:endParaRPr lang="en-US"/>
           </a:p>
@@ -5270,9 +5163,9 @@
 </p:sld>
 </file>
 
-<file path=ppt/slides/slide15.xml><?xml version="1.0" encoding="utf-8"?>
+<file path=ppt/slides/slide16.xml><?xml version="1.0" encoding="utf-8"?>
 <p:sld xmlns:a="http://schemas.openxmlformats.org/drawingml/2006/main" xmlns:r="http://schemas.openxmlformats.org/officeDocument/2006/relationships" xmlns:p="http://schemas.openxmlformats.org/presentationml/2006/main">
-  <p:cSld name="Slide 15">
+  <p:cSld name="Slide 16">
     <p:spTree>
       <p:nvGrpSpPr>
         <p:cNvPr id="1" name=""/>
@@ -5327,7 +5220,7 @@
       </p:sp>
       <p:graphicFrame>
         <p:nvGraphicFramePr>
-          <p:cNvPr id="16" name="Reference list"/>
+          <p:cNvPr id="17" name="Reference list"/>
           <p:cNvGraphicFramePr>
             <a:graphicFrameLocks noGrp="1"/>
           </p:cNvGraphicFramePr>
@@ -5340,7 +5233,7 @@
           </p:nvPr>
         </p:nvGraphicFramePr>
         <p:xfrm>
-          <a:off x="228600" y="2153412"/>
+          <a:off x="228600" y="1956816"/>
           <a:ext cx="8686800" cy="914400"/>
         </p:xfrm>
         <a:graphic>
@@ -5367,6 +5260,92 @@
                           </a:solidFill>
                         </a:rPr>
                         <a:t>[9]</a:t>
+                      </a:r>
+                      <a:endParaRPr lang="en-US" sz="1050" dirty="0"/>
+                    </a:p>
+                  </a:txBody>
+                  <a:tcPr marL="25400" marR="25400" marT="25400" marB="25400" anchor="t">
+                    <a:lnL w="0" cap="flat" cmpd="sng" algn="ctr">
+                      <a:noFill/>
+                    </a:lnL>
+                    <a:lnR w="0" cap="flat" cmpd="sng" algn="ctr">
+                      <a:noFill/>
+                    </a:lnR>
+                    <a:lnT w="0" cap="flat" cmpd="sng" algn="ctr">
+                      <a:noFill/>
+                    </a:lnT>
+                    <a:lnB w="0" cap="flat" cmpd="sng" algn="ctr">
+                      <a:noFill/>
+                    </a:lnB>
+                  </a:tcPr>
+                </a:tc>
+                <a:tc>
+                  <a:txBody>
+                    <a:bodyPr/>
+                    <a:lstStyle/>
+                    <a:p>
+                      <a:pPr indent="0" marL="0">
+                        <a:buNone/>
+                      </a:pPr>
+                      <a:r>
+                        <a:rPr lang="en-US" sz="1050" dirty="0">
+                          <a:solidFill>
+                            <a:schemeClr val="tx1"/>
+                          </a:solidFill>
+                        </a:rPr>
+                        <a:t>Chanathip Pornprasit and Chakkrit Tantithamthavorn. “JITLine: A Simpler, Better, Faster, Finer-grained Just-In-Time Defect Prediction”. </a:t>
+                      </a:r>
+                      <a:r>
+                        <a:rPr lang="en-US" sz="1050" dirty="0">
+                          <a:solidFill>
+                            <a:schemeClr val="tx2"/>
+                          </a:solidFill>
+                        </a:rPr>
+                        <a:t>In: </a:t>
+                      </a:r>
+                      <a:r>
+                        <a:rPr lang="en-US" sz="1050" i="1" dirty="0">
+                          <a:solidFill>
+                            <a:schemeClr val="tx2"/>
+                          </a:solidFill>
+                        </a:rPr>
+                        <a:t>Proceedings of the 18th International Conference on Mining Software Repositories (MSR). 2021, pp. 369-379.</a:t>
+                      </a:r>
+                      <a:endParaRPr lang="en-US" sz="1050" dirty="0"/>
+                    </a:p>
+                  </a:txBody>
+                  <a:tcPr marL="25400" marR="25400" marT="25400" marB="25400" anchor="t">
+                    <a:lnL w="0" cap="flat" cmpd="sng" algn="ctr">
+                      <a:noFill/>
+                    </a:lnL>
+                    <a:lnR w="0" cap="flat" cmpd="sng" algn="ctr">
+                      <a:noFill/>
+                    </a:lnR>
+                    <a:lnT w="0" cap="flat" cmpd="sng" algn="ctr">
+                      <a:noFill/>
+                    </a:lnT>
+                    <a:lnB w="0" cap="flat" cmpd="sng" algn="ctr">
+                      <a:noFill/>
+                    </a:lnB>
+                  </a:tcPr>
+                </a:tc>
+              </a:tr>
+              <a:tr h="0">
+                <a:tc>
+                  <a:txBody>
+                    <a:bodyPr/>
+                    <a:lstStyle/>
+                    <a:p>
+                      <a:pPr indent="0" marL="0">
+                        <a:buNone/>
+                      </a:pPr>
+                      <a:r>
+                        <a:rPr lang="en-US" sz="1050" dirty="0">
+                          <a:solidFill>
+                            <a:schemeClr val="tx2"/>
+                          </a:solidFill>
+                        </a:rPr>
+                        <a:t>[10]</a:t>
                       </a:r>
                       <a:endParaRPr lang="en-US" sz="1050" dirty="0"/>
                     </a:p>
@@ -5452,7 +5431,7 @@
                             <a:schemeClr val="tx2"/>
                           </a:solidFill>
                         </a:rPr>
-                        <a:t>[10]</a:t>
+                        <a:t>[11]</a:t>
                       </a:r>
                       <a:endParaRPr lang="en-US" sz="1050" dirty="0"/>
                     </a:p>
@@ -5538,7 +5517,7 @@
                             <a:schemeClr val="tx2"/>
                           </a:solidFill>
                         </a:rPr>
-                        <a:t>[11]</a:t>
+                        <a:t>[12]</a:t>
                       </a:r>
                       <a:endParaRPr lang="en-US" sz="1050" dirty="0"/>
                     </a:p>
@@ -5652,7 +5631,7 @@
             <a:pPr algn="r"/>
             <a:fld id="{F7021451-1387-4CA6-816F-3879F97B5CBC}" type="slidenum">
               <a:rPr b="0" lang="en-US"/>
-              <a:t>15</a:t>
+              <a:t>16</a:t>
             </a:fld>
             <a:endParaRPr lang="en-US"/>
           </a:p>
@@ -5834,7 +5813,7 @@
                   <a:schemeClr val="tx1"/>
                 </a:solidFill>
               </a:rPr>
-              <a:t>Research Questions and Objectives</a:t>
+              <a:t>Objectives and Research Questions</a:t>
             </a:r>
             <a:endParaRPr lang="en-US" sz="1700" dirty="0"/>
           </a:p>
@@ -5872,26 +5851,7 @@
                   <a:schemeClr val="tx1"/>
                 </a:solidFill>
               </a:rPr>
-              <a:t>Proposed Work</a:t>
-            </a:r>
-            <a:endParaRPr lang="en-US" sz="1700" dirty="0"/>
-          </a:p>
-          <a:p>
-            <a:pPr marL="342900" indent="-342900">
-              <a:spcAft>
-                <a:spcPts val="600"/>
-              </a:spcAft>
-              <a:buSzPct val="100000"/>
-              <a:buFont typeface="+mj-lt"/>
-              <a:buAutoNum type="arabicPeriod" startAt="1"/>
-            </a:pPr>
-            <a:r>
-              <a:rPr lang="en-US" sz="1700" dirty="0">
-                <a:solidFill>
-                  <a:schemeClr val="tx1"/>
-                </a:solidFill>
-              </a:rPr>
-              <a:t>Timeline</a:t>
+              <a:t>Proposed Methodology</a:t>
             </a:r>
             <a:endParaRPr lang="en-US" sz="1700" dirty="0"/>
           </a:p>
@@ -6096,7 +6056,7 @@
                   <a:schemeClr val="tx1"/>
                 </a:solidFill>
               </a:rPr>
-              <a:t>These labels are not recorded in the repository. They are inferred by the SZZ algorithm, which traces the lines changed in a bug-fixing commit back to the commits that last modified them [10].</a:t>
+              <a:t>These labels are not recorded in the repository. They are inferred by the SZZ algorithm, which traces the lines changed in a bug-fixing commit back to the commits that last modified them [11].</a:t>
             </a:r>
             <a:endParaRPr lang="en-US" sz="1700" dirty="0"/>
           </a:p>
@@ -6905,7 +6865,7 @@
                             <a:schemeClr val="tx1"/>
                           </a:solidFill>
                         </a:rPr>
-                        <a:t>When Do Changes Induce Fixes? (2005) [10]</a:t>
+                        <a:t>When Do Changes Induce Fixes? (2005) [11]</a:t>
                       </a:r>
                       <a:endParaRPr lang="en-US" sz="1050" dirty="0"/>
                     </a:p>
@@ -7229,7 +7189,7 @@
                             <a:schemeClr val="tx1"/>
                           </a:solidFill>
                         </a:rPr>
-                        <a:t>Evaluating SZZ Implementations Through a Developer-Informed Oracle (2021) [9]</a:t>
+                        <a:t>Evaluating SZZ Implementations Through a Developer-Informed Oracle (2021) [10]</a:t>
                       </a:r>
                       <a:endParaRPr lang="en-US" sz="1050" dirty="0"/>
                     </a:p>
@@ -8527,7 +8487,7 @@
                             <a:schemeClr val="tx1"/>
                           </a:solidFill>
                         </a:rPr>
-                        <a:t>Deep Just-in-Time Defect Prediction: How Far Are We? (2021) [11]</a:t>
+                        <a:t>Deep Just-in-Time Defect Prediction: How Far Are We? (2021) [12]</a:t>
                       </a:r>
                       <a:endParaRPr lang="en-US" sz="1050" dirty="0"/>
                     </a:p>
@@ -9164,7 +9124,7 @@
                   <a:schemeClr val="bg1"/>
                 </a:solidFill>
               </a:rPr>
-              <a:t>Research Questions</a:t>
+              <a:t>Objectives</a:t>
             </a:r>
             <a:endParaRPr lang="en-US" sz="2400" dirty="0"/>
           </a:p>
@@ -9206,7 +9166,7 @@
                   <a:schemeClr val="tx1"/>
                 </a:solidFill>
               </a:rPr>
-              <a:t>RQ1: </a:t>
+              <a:t>Objective 1: </a:t>
             </a:r>
             <a:r>
               <a:rPr lang="en-US" sz="1700" dirty="0">
@@ -9214,7 +9174,7 @@
                   <a:schemeClr val="tx1"/>
                 </a:solidFill>
               </a:rPr>
-              <a:t>How much do the labels of SZZ variants disagree with one another and with independent reference labels, and what type of error does each variant make?</a:t>
+              <a:t>To quantify the label noise introduced by SZZ and its variants, by comparing their labels with independent reference labels over complete project histories.</a:t>
             </a:r>
             <a:endParaRPr lang="en-US" sz="1700" dirty="0"/>
           </a:p>
@@ -9232,7 +9192,7 @@
                   <a:schemeClr val="tx1"/>
                 </a:solidFill>
               </a:rPr>
-              <a:t>RQ2: </a:t>
+              <a:t>Objective 2: </a:t>
             </a:r>
             <a:r>
               <a:rPr lang="en-US" sz="1700" dirty="0">
@@ -9240,7 +9200,7 @@
                   <a:schemeClr val="tx1"/>
                 </a:solidFill>
               </a:rPr>
-              <a:t>How does the choice of the label source affect the measured performance of JIT-SDP models under different evaluation settings?</a:t>
+              <a:t>To measure the effect of this noise on JIT-SDP models under a realistic evaluation that respects the order of the commits and the delay of the labels, and to separate it from the effect of the evaluation procedure.</a:t>
             </a:r>
             <a:endParaRPr lang="en-US" sz="1700" dirty="0"/>
           </a:p>
@@ -9258,7 +9218,7 @@
                   <a:schemeClr val="tx1"/>
                 </a:solidFill>
               </a:rPr>
-              <a:t>RQ3: </a:t>
+              <a:t>Objective 3: </a:t>
             </a:r>
             <a:r>
               <a:rPr lang="en-US" sz="1700" dirty="0">
@@ -9266,33 +9226,7 @@
                   <a:schemeClr val="tx1"/>
                 </a:solidFill>
               </a:rPr>
-              <a:t>Through which mechanism does label noise reduce the performance of an online learner, and which type of error is responsible?</a:t>
-            </a:r>
-            <a:endParaRPr lang="en-US" sz="1700" dirty="0"/>
-          </a:p>
-          <a:p>
-            <a:pPr marL="177800" indent="-177800">
-              <a:spcAft>
-                <a:spcPts val="600"/>
-              </a:spcAft>
-              <a:buSzPct val="100000"/>
-              <a:buChar char="•"/>
-            </a:pPr>
-            <a:r>
-              <a:rPr lang="en-US" sz="1700" b="1" dirty="0">
-                <a:solidFill>
-                  <a:schemeClr val="tx1"/>
-                </a:solidFill>
-              </a:rPr>
-              <a:t>RQ4: </a:t>
-            </a:r>
-            <a:r>
-              <a:rPr lang="en-US" sz="1700" dirty="0">
-                <a:solidFill>
-                  <a:schemeClr val="tx1"/>
-                </a:solidFill>
-              </a:rPr>
-              <a:t>Can an online learner be made less sensitive to SZZ label noise without access to clean labels?</a:t>
+              <a:t>To identify how the noise affects an online learner, and to develop a noise-aware online learning approach that reduces its effect.</a:t>
             </a:r>
             <a:endParaRPr lang="en-US" sz="1700" dirty="0"/>
           </a:p>

</xml_diff>